<commit_message>
changed user stories ID's
</commit_message>
<xml_diff>
--- a/LB_426_Personas.pptx
+++ b/LB_426_Personas.pptx
@@ -517,7 +517,7 @@
           <a:lstStyle/>
           <a:p>
             <a:fld id="{DB8FDF6C-9B07-4782-AA2B-07EAA2872B3C}" type="datetimeFigureOut">
-              <a:t>03.09.2026</a:t>
+              <a:t>17.09.2026</a:t>
             </a:fld>
             <a:endParaRPr/>
           </a:p>
@@ -712,7 +712,7 @@
           <a:lstStyle/>
           <a:p>
             <a:fld id="{DB8FDF6C-9B07-4782-AA2B-07EAA2872B3C}" type="datetimeFigureOut">
-              <a:t>03.09.2026</a:t>
+              <a:t>17.09.2026</a:t>
             </a:fld>
             <a:endParaRPr/>
           </a:p>
@@ -917,7 +917,7 @@
           <a:lstStyle/>
           <a:p>
             <a:fld id="{DB8FDF6C-9B07-4782-AA2B-07EAA2872B3C}" type="datetimeFigureOut">
-              <a:t>03.09.2026</a:t>
+              <a:t>17.09.2026</a:t>
             </a:fld>
             <a:endParaRPr/>
           </a:p>
@@ -1112,7 +1112,7 @@
           <a:lstStyle/>
           <a:p>
             <a:fld id="{DB8FDF6C-9B07-4782-AA2B-07EAA2872B3C}" type="datetimeFigureOut">
-              <a:t>03.09.2026</a:t>
+              <a:t>17.09.2026</a:t>
             </a:fld>
             <a:endParaRPr/>
           </a:p>
@@ -1379,7 +1379,7 @@
           <a:lstStyle/>
           <a:p>
             <a:fld id="{DB8FDF6C-9B07-4782-AA2B-07EAA2872B3C}" type="datetimeFigureOut">
-              <a:t>03.09.2026</a:t>
+              <a:t>17.09.2026</a:t>
             </a:fld>
             <a:endParaRPr/>
           </a:p>
@@ -1646,7 +1646,7 @@
           <a:lstStyle/>
           <a:p>
             <a:fld id="{DB8FDF6C-9B07-4782-AA2B-07EAA2872B3C}" type="datetimeFigureOut">
-              <a:t>03.09.2026</a:t>
+              <a:t>17.09.2026</a:t>
             </a:fld>
             <a:endParaRPr/>
           </a:p>
@@ -2062,7 +2062,7 @@
           <a:lstStyle/>
           <a:p>
             <a:fld id="{DB8FDF6C-9B07-4782-AA2B-07EAA2872B3C}" type="datetimeFigureOut">
-              <a:t>03.09.2026</a:t>
+              <a:t>17.09.2026</a:t>
             </a:fld>
             <a:endParaRPr/>
           </a:p>
@@ -2195,7 +2195,7 @@
           <a:lstStyle/>
           <a:p>
             <a:fld id="{DB8FDF6C-9B07-4782-AA2B-07EAA2872B3C}" type="datetimeFigureOut">
-              <a:t>03.09.2026</a:t>
+              <a:t>17.09.2026</a:t>
             </a:fld>
             <a:endParaRPr/>
           </a:p>
@@ -2301,7 +2301,7 @@
           <a:lstStyle/>
           <a:p>
             <a:fld id="{DB8FDF6C-9B07-4782-AA2B-07EAA2872B3C}" type="datetimeFigureOut">
-              <a:t>03.09.2026</a:t>
+              <a:t>17.09.2026</a:t>
             </a:fld>
             <a:endParaRPr/>
           </a:p>
@@ -2620,7 +2620,7 @@
           <a:lstStyle/>
           <a:p>
             <a:fld id="{DB8FDF6C-9B07-4782-AA2B-07EAA2872B3C}" type="datetimeFigureOut">
-              <a:t>03.09.2026</a:t>
+              <a:t>17.09.2026</a:t>
             </a:fld>
             <a:endParaRPr/>
           </a:p>
@@ -2904,7 +2904,7 @@
           <a:lstStyle/>
           <a:p>
             <a:fld id="{DB8FDF6C-9B07-4782-AA2B-07EAA2872B3C}" type="datetimeFigureOut">
-              <a:t>03.09.2026</a:t>
+              <a:t>17.09.2026</a:t>
             </a:fld>
             <a:endParaRPr/>
           </a:p>
@@ -3143,7 +3143,7 @@
           </a:lstStyle>
           <a:p>
             <a:fld id="{DB8FDF6C-9B07-4782-AA2B-07EAA2872B3C}" type="datetimeFigureOut">
-              <a:t>03.09.2026</a:t>
+              <a:t>17.09.2026</a:t>
             </a:fld>
             <a:endParaRPr/>
           </a:p>
@@ -24735,17 +24735,577 @@
           </a:lstStyle>
           <a:p>
             <a:r>
-              <a:rPr sz="1000">
-                <a:latin typeface="Arial"/>
-                <a:ea typeface="Arial"/>
-                <a:cs typeface="Arial"/>
-              </a:rPr>
-              <a:t>US-005: Als Roulette-Spielerin möchte ich auf Rot oder Schwarz setzen, damit ich mit hoher Trefferchance spiele.
-Akzeptanz: Farbtreffer zahlt 1:1; bei der 0 sind Farbeinsätze verloren.
-US-006: Als Roulette-Spielerin möchte ich mehrere Felder gleichzeitig besetzen, damit ich meine Verluste breiter streue.
-Akzeptanz: Summe aller Einsätze ≤ Guthaben; Nummer zahlt 35:1; Übersicht vor dem Dreh.</a:t>
-            </a:r>
-            <a:endParaRPr sz="1200">
+              <a:rPr sz="1000" dirty="0">
+                <a:latin typeface="Arial"/>
+                <a:ea typeface="Arial"/>
+                <a:cs typeface="Arial"/>
+              </a:rPr>
+              <a:t>US-00</a:t>
+            </a:r>
+            <a:r>
+              <a:rPr lang="de-CH" sz="1000" dirty="0">
+                <a:latin typeface="Arial"/>
+                <a:ea typeface="Arial"/>
+                <a:cs typeface="Arial"/>
+              </a:rPr>
+              <a:t>4</a:t>
+            </a:r>
+            <a:r>
+              <a:rPr sz="1000" dirty="0">
+                <a:latin typeface="Arial"/>
+                <a:ea typeface="Arial"/>
+                <a:cs typeface="Arial"/>
+              </a:rPr>
+              <a:t>: Als Roulette-</a:t>
+            </a:r>
+            <a:r>
+              <a:rPr sz="1000" dirty="0" err="1">
+                <a:latin typeface="Arial"/>
+                <a:ea typeface="Arial"/>
+                <a:cs typeface="Arial"/>
+              </a:rPr>
+              <a:t>Spielerin</a:t>
+            </a:r>
+            <a:r>
+              <a:rPr sz="1000" dirty="0">
+                <a:latin typeface="Arial"/>
+                <a:ea typeface="Arial"/>
+                <a:cs typeface="Arial"/>
+              </a:rPr>
+              <a:t> </a:t>
+            </a:r>
+            <a:r>
+              <a:rPr sz="1000" dirty="0" err="1">
+                <a:latin typeface="Arial"/>
+                <a:ea typeface="Arial"/>
+                <a:cs typeface="Arial"/>
+              </a:rPr>
+              <a:t>möchte</a:t>
+            </a:r>
+            <a:r>
+              <a:rPr sz="1000" dirty="0">
+                <a:latin typeface="Arial"/>
+                <a:ea typeface="Arial"/>
+                <a:cs typeface="Arial"/>
+              </a:rPr>
+              <a:t> ich auf Rot </a:t>
+            </a:r>
+            <a:r>
+              <a:rPr sz="1000" dirty="0" err="1">
+                <a:latin typeface="Arial"/>
+                <a:ea typeface="Arial"/>
+                <a:cs typeface="Arial"/>
+              </a:rPr>
+              <a:t>oder</a:t>
+            </a:r>
+            <a:r>
+              <a:rPr sz="1000" dirty="0">
+                <a:latin typeface="Arial"/>
+                <a:ea typeface="Arial"/>
+                <a:cs typeface="Arial"/>
+              </a:rPr>
+              <a:t> Schwarz </a:t>
+            </a:r>
+            <a:r>
+              <a:rPr sz="1000" dirty="0" err="1">
+                <a:latin typeface="Arial"/>
+                <a:ea typeface="Arial"/>
+                <a:cs typeface="Arial"/>
+              </a:rPr>
+              <a:t>setzen</a:t>
+            </a:r>
+            <a:r>
+              <a:rPr sz="1000" dirty="0">
+                <a:latin typeface="Arial"/>
+                <a:ea typeface="Arial"/>
+                <a:cs typeface="Arial"/>
+              </a:rPr>
+              <a:t>, </a:t>
+            </a:r>
+            <a:r>
+              <a:rPr sz="1000" dirty="0" err="1">
+                <a:latin typeface="Arial"/>
+                <a:ea typeface="Arial"/>
+                <a:cs typeface="Arial"/>
+              </a:rPr>
+              <a:t>damit</a:t>
+            </a:r>
+            <a:r>
+              <a:rPr sz="1000" dirty="0">
+                <a:latin typeface="Arial"/>
+                <a:ea typeface="Arial"/>
+                <a:cs typeface="Arial"/>
+              </a:rPr>
+              <a:t> ich </a:t>
+            </a:r>
+            <a:r>
+              <a:rPr sz="1000" dirty="0" err="1">
+                <a:latin typeface="Arial"/>
+                <a:ea typeface="Arial"/>
+                <a:cs typeface="Arial"/>
+              </a:rPr>
+              <a:t>mit</a:t>
+            </a:r>
+            <a:r>
+              <a:rPr sz="1000" dirty="0">
+                <a:latin typeface="Arial"/>
+                <a:ea typeface="Arial"/>
+                <a:cs typeface="Arial"/>
+              </a:rPr>
+              <a:t> </a:t>
+            </a:r>
+            <a:r>
+              <a:rPr sz="1000" dirty="0" err="1">
+                <a:latin typeface="Arial"/>
+                <a:ea typeface="Arial"/>
+                <a:cs typeface="Arial"/>
+              </a:rPr>
+              <a:t>hoher</a:t>
+            </a:r>
+            <a:r>
+              <a:rPr sz="1000" dirty="0">
+                <a:latin typeface="Arial"/>
+                <a:ea typeface="Arial"/>
+                <a:cs typeface="Arial"/>
+              </a:rPr>
+              <a:t> </a:t>
+            </a:r>
+            <a:r>
+              <a:rPr sz="1000" dirty="0" err="1">
+                <a:latin typeface="Arial"/>
+                <a:ea typeface="Arial"/>
+                <a:cs typeface="Arial"/>
+              </a:rPr>
+              <a:t>Trefferchance</a:t>
+            </a:r>
+            <a:r>
+              <a:rPr sz="1000" dirty="0">
+                <a:latin typeface="Arial"/>
+                <a:ea typeface="Arial"/>
+                <a:cs typeface="Arial"/>
+              </a:rPr>
+              <a:t> </a:t>
+            </a:r>
+            <a:r>
+              <a:rPr sz="1000" dirty="0" err="1">
+                <a:latin typeface="Arial"/>
+                <a:ea typeface="Arial"/>
+                <a:cs typeface="Arial"/>
+              </a:rPr>
+              <a:t>spiele</a:t>
+            </a:r>
+            <a:r>
+              <a:rPr sz="1000" dirty="0">
+                <a:latin typeface="Arial"/>
+                <a:ea typeface="Arial"/>
+                <a:cs typeface="Arial"/>
+              </a:rPr>
+              <a:t>.
+</a:t>
+            </a:r>
+            <a:r>
+              <a:rPr sz="1000" dirty="0" err="1">
+                <a:latin typeface="Arial"/>
+                <a:ea typeface="Arial"/>
+                <a:cs typeface="Arial"/>
+              </a:rPr>
+              <a:t>Akzeptanz</a:t>
+            </a:r>
+            <a:r>
+              <a:rPr sz="1000" dirty="0">
+                <a:latin typeface="Arial"/>
+                <a:ea typeface="Arial"/>
+                <a:cs typeface="Arial"/>
+              </a:rPr>
+              <a:t>: </a:t>
+            </a:r>
+            <a:r>
+              <a:rPr sz="1000" dirty="0" err="1">
+                <a:latin typeface="Arial"/>
+                <a:ea typeface="Arial"/>
+                <a:cs typeface="Arial"/>
+              </a:rPr>
+              <a:t>Farbtreffer</a:t>
+            </a:r>
+            <a:r>
+              <a:rPr sz="1000" dirty="0">
+                <a:latin typeface="Arial"/>
+                <a:ea typeface="Arial"/>
+                <a:cs typeface="Arial"/>
+              </a:rPr>
+              <a:t> </a:t>
+            </a:r>
+            <a:r>
+              <a:rPr sz="1000" dirty="0" err="1">
+                <a:latin typeface="Arial"/>
+                <a:ea typeface="Arial"/>
+                <a:cs typeface="Arial"/>
+              </a:rPr>
+              <a:t>zahlt</a:t>
+            </a:r>
+            <a:r>
+              <a:rPr sz="1000" dirty="0">
+                <a:latin typeface="Arial"/>
+                <a:ea typeface="Arial"/>
+                <a:cs typeface="Arial"/>
+              </a:rPr>
+              <a:t> 1:1; </a:t>
+            </a:r>
+            <a:r>
+              <a:rPr sz="1000" dirty="0" err="1">
+                <a:latin typeface="Arial"/>
+                <a:ea typeface="Arial"/>
+                <a:cs typeface="Arial"/>
+              </a:rPr>
+              <a:t>bei</a:t>
+            </a:r>
+            <a:r>
+              <a:rPr sz="1000" dirty="0">
+                <a:latin typeface="Arial"/>
+                <a:ea typeface="Arial"/>
+                <a:cs typeface="Arial"/>
+              </a:rPr>
+              <a:t> der 0 </a:t>
+            </a:r>
+            <a:r>
+              <a:rPr sz="1000" dirty="0" err="1">
+                <a:latin typeface="Arial"/>
+                <a:ea typeface="Arial"/>
+                <a:cs typeface="Arial"/>
+              </a:rPr>
+              <a:t>sind</a:t>
+            </a:r>
+            <a:r>
+              <a:rPr sz="1000" dirty="0">
+                <a:latin typeface="Arial"/>
+                <a:ea typeface="Arial"/>
+                <a:cs typeface="Arial"/>
+              </a:rPr>
+              <a:t> </a:t>
+            </a:r>
+            <a:r>
+              <a:rPr sz="1000" dirty="0" err="1">
+                <a:latin typeface="Arial"/>
+                <a:ea typeface="Arial"/>
+                <a:cs typeface="Arial"/>
+              </a:rPr>
+              <a:t>Farbeinsätze</a:t>
+            </a:r>
+            <a:r>
+              <a:rPr sz="1000" dirty="0">
+                <a:latin typeface="Arial"/>
+                <a:ea typeface="Arial"/>
+                <a:cs typeface="Arial"/>
+              </a:rPr>
+              <a:t> </a:t>
+            </a:r>
+            <a:r>
+              <a:rPr sz="1000" dirty="0" err="1">
+                <a:latin typeface="Arial"/>
+                <a:ea typeface="Arial"/>
+                <a:cs typeface="Arial"/>
+              </a:rPr>
+              <a:t>verloren</a:t>
+            </a:r>
+            <a:r>
+              <a:rPr sz="1000" dirty="0">
+                <a:latin typeface="Arial"/>
+                <a:ea typeface="Arial"/>
+                <a:cs typeface="Arial"/>
+              </a:rPr>
+              <a:t>.
+US-006: Als Roulette-</a:t>
+            </a:r>
+            <a:r>
+              <a:rPr sz="1000" dirty="0" err="1">
+                <a:latin typeface="Arial"/>
+                <a:ea typeface="Arial"/>
+                <a:cs typeface="Arial"/>
+              </a:rPr>
+              <a:t>Spielerin</a:t>
+            </a:r>
+            <a:r>
+              <a:rPr sz="1000" dirty="0">
+                <a:latin typeface="Arial"/>
+                <a:ea typeface="Arial"/>
+                <a:cs typeface="Arial"/>
+              </a:rPr>
+              <a:t> </a:t>
+            </a:r>
+            <a:r>
+              <a:rPr sz="1000" dirty="0" err="1">
+                <a:latin typeface="Arial"/>
+                <a:ea typeface="Arial"/>
+                <a:cs typeface="Arial"/>
+              </a:rPr>
+              <a:t>möchte</a:t>
+            </a:r>
+            <a:r>
+              <a:rPr sz="1000" dirty="0">
+                <a:latin typeface="Arial"/>
+                <a:ea typeface="Arial"/>
+                <a:cs typeface="Arial"/>
+              </a:rPr>
+              <a:t> ich </a:t>
+            </a:r>
+            <a:r>
+              <a:rPr sz="1000" dirty="0" err="1">
+                <a:latin typeface="Arial"/>
+                <a:ea typeface="Arial"/>
+                <a:cs typeface="Arial"/>
+              </a:rPr>
+              <a:t>mehrere</a:t>
+            </a:r>
+            <a:r>
+              <a:rPr sz="1000" dirty="0">
+                <a:latin typeface="Arial"/>
+                <a:ea typeface="Arial"/>
+                <a:cs typeface="Arial"/>
+              </a:rPr>
+              <a:t> Felder </a:t>
+            </a:r>
+            <a:r>
+              <a:rPr sz="1000" dirty="0" err="1">
+                <a:latin typeface="Arial"/>
+                <a:ea typeface="Arial"/>
+                <a:cs typeface="Arial"/>
+              </a:rPr>
+              <a:t>gleichzeitig</a:t>
+            </a:r>
+            <a:r>
+              <a:rPr sz="1000" dirty="0">
+                <a:latin typeface="Arial"/>
+                <a:ea typeface="Arial"/>
+                <a:cs typeface="Arial"/>
+              </a:rPr>
+              <a:t> </a:t>
+            </a:r>
+            <a:r>
+              <a:rPr sz="1000" dirty="0" err="1">
+                <a:latin typeface="Arial"/>
+                <a:ea typeface="Arial"/>
+                <a:cs typeface="Arial"/>
+              </a:rPr>
+              <a:t>besetzen</a:t>
+            </a:r>
+            <a:r>
+              <a:rPr sz="1000" dirty="0">
+                <a:latin typeface="Arial"/>
+                <a:ea typeface="Arial"/>
+                <a:cs typeface="Arial"/>
+              </a:rPr>
+              <a:t>, </a:t>
+            </a:r>
+            <a:r>
+              <a:rPr sz="1000" dirty="0" err="1">
+                <a:latin typeface="Arial"/>
+                <a:ea typeface="Arial"/>
+                <a:cs typeface="Arial"/>
+              </a:rPr>
+              <a:t>damit</a:t>
+            </a:r>
+            <a:r>
+              <a:rPr sz="1000" dirty="0">
+                <a:latin typeface="Arial"/>
+                <a:ea typeface="Arial"/>
+                <a:cs typeface="Arial"/>
+              </a:rPr>
+              <a:t> ich </a:t>
+            </a:r>
+            <a:r>
+              <a:rPr sz="1000" dirty="0" err="1">
+                <a:latin typeface="Arial"/>
+                <a:ea typeface="Arial"/>
+                <a:cs typeface="Arial"/>
+              </a:rPr>
+              <a:t>meine</a:t>
+            </a:r>
+            <a:r>
+              <a:rPr sz="1000" dirty="0">
+                <a:latin typeface="Arial"/>
+                <a:ea typeface="Arial"/>
+                <a:cs typeface="Arial"/>
+              </a:rPr>
+              <a:t> </a:t>
+            </a:r>
+            <a:r>
+              <a:rPr sz="1000" dirty="0" err="1">
+                <a:latin typeface="Arial"/>
+                <a:ea typeface="Arial"/>
+                <a:cs typeface="Arial"/>
+              </a:rPr>
+              <a:t>Verluste</a:t>
+            </a:r>
+            <a:r>
+              <a:rPr sz="1000" dirty="0">
+                <a:latin typeface="Arial"/>
+                <a:ea typeface="Arial"/>
+                <a:cs typeface="Arial"/>
+              </a:rPr>
+              <a:t> </a:t>
+            </a:r>
+            <a:r>
+              <a:rPr sz="1000" dirty="0" err="1">
+                <a:latin typeface="Arial"/>
+                <a:ea typeface="Arial"/>
+                <a:cs typeface="Arial"/>
+              </a:rPr>
+              <a:t>breiter</a:t>
+            </a:r>
+            <a:r>
+              <a:rPr sz="1000" dirty="0">
+                <a:latin typeface="Arial"/>
+                <a:ea typeface="Arial"/>
+                <a:cs typeface="Arial"/>
+              </a:rPr>
+              <a:t> </a:t>
+            </a:r>
+            <a:r>
+              <a:rPr sz="1000" dirty="0" err="1">
+                <a:latin typeface="Arial"/>
+                <a:ea typeface="Arial"/>
+                <a:cs typeface="Arial"/>
+              </a:rPr>
+              <a:t>streue</a:t>
+            </a:r>
+            <a:r>
+              <a:rPr sz="1000" dirty="0">
+                <a:latin typeface="Arial"/>
+                <a:ea typeface="Arial"/>
+                <a:cs typeface="Arial"/>
+              </a:rPr>
+              <a:t>.
+</a:t>
+            </a:r>
+            <a:r>
+              <a:rPr sz="1000" dirty="0" err="1">
+                <a:latin typeface="Arial"/>
+                <a:ea typeface="Arial"/>
+                <a:cs typeface="Arial"/>
+              </a:rPr>
+              <a:t>Akzeptanz</a:t>
+            </a:r>
+            <a:r>
+              <a:rPr sz="1000" dirty="0">
+                <a:latin typeface="Arial"/>
+                <a:ea typeface="Arial"/>
+                <a:cs typeface="Arial"/>
+              </a:rPr>
+              <a:t>: Summe </a:t>
+            </a:r>
+            <a:r>
+              <a:rPr sz="1000" dirty="0" err="1">
+                <a:latin typeface="Arial"/>
+                <a:ea typeface="Arial"/>
+                <a:cs typeface="Arial"/>
+              </a:rPr>
+              <a:t>aller</a:t>
+            </a:r>
+            <a:r>
+              <a:rPr sz="1000" dirty="0">
+                <a:latin typeface="Arial"/>
+                <a:ea typeface="Arial"/>
+                <a:cs typeface="Arial"/>
+              </a:rPr>
+              <a:t> </a:t>
+            </a:r>
+            <a:r>
+              <a:rPr sz="1000" dirty="0" err="1">
+                <a:latin typeface="Arial"/>
+                <a:ea typeface="Arial"/>
+                <a:cs typeface="Arial"/>
+              </a:rPr>
+              <a:t>Einsätze</a:t>
+            </a:r>
+            <a:r>
+              <a:rPr sz="1000" dirty="0">
+                <a:latin typeface="Arial"/>
+                <a:ea typeface="Arial"/>
+                <a:cs typeface="Arial"/>
+              </a:rPr>
+              <a:t> ≤ </a:t>
+            </a:r>
+            <a:r>
+              <a:rPr sz="1000" dirty="0" err="1">
+                <a:latin typeface="Arial"/>
+                <a:ea typeface="Arial"/>
+                <a:cs typeface="Arial"/>
+              </a:rPr>
+              <a:t>Guthaben</a:t>
+            </a:r>
+            <a:r>
+              <a:rPr sz="1000" dirty="0">
+                <a:latin typeface="Arial"/>
+                <a:ea typeface="Arial"/>
+                <a:cs typeface="Arial"/>
+              </a:rPr>
+              <a:t>; Nummer </a:t>
+            </a:r>
+            <a:r>
+              <a:rPr sz="1000" dirty="0" err="1">
+                <a:latin typeface="Arial"/>
+                <a:ea typeface="Arial"/>
+                <a:cs typeface="Arial"/>
+              </a:rPr>
+              <a:t>zahlt</a:t>
+            </a:r>
+            <a:r>
+              <a:rPr sz="1000" dirty="0">
+                <a:latin typeface="Arial"/>
+                <a:ea typeface="Arial"/>
+                <a:cs typeface="Arial"/>
+              </a:rPr>
+              <a:t> 35:1; </a:t>
+            </a:r>
+            <a:r>
+              <a:rPr sz="1000" dirty="0" err="1">
+                <a:latin typeface="Arial"/>
+                <a:ea typeface="Arial"/>
+                <a:cs typeface="Arial"/>
+              </a:rPr>
+              <a:t>Übersicht</a:t>
+            </a:r>
+            <a:r>
+              <a:rPr sz="1000" dirty="0">
+                <a:latin typeface="Arial"/>
+                <a:ea typeface="Arial"/>
+                <a:cs typeface="Arial"/>
+              </a:rPr>
+              <a:t> </a:t>
+            </a:r>
+            <a:r>
+              <a:rPr sz="1000" dirty="0" err="1">
+                <a:latin typeface="Arial"/>
+                <a:ea typeface="Arial"/>
+                <a:cs typeface="Arial"/>
+              </a:rPr>
+              <a:t>vor</a:t>
+            </a:r>
+            <a:r>
+              <a:rPr sz="1000" dirty="0">
+                <a:latin typeface="Arial"/>
+                <a:ea typeface="Arial"/>
+                <a:cs typeface="Arial"/>
+              </a:rPr>
+              <a:t> dem </a:t>
+            </a:r>
+            <a:r>
+              <a:rPr sz="1000" dirty="0" err="1">
+                <a:latin typeface="Arial"/>
+                <a:ea typeface="Arial"/>
+                <a:cs typeface="Arial"/>
+              </a:rPr>
+              <a:t>Dreh</a:t>
+            </a:r>
+            <a:r>
+              <a:rPr sz="1000" dirty="0">
+                <a:latin typeface="Arial"/>
+                <a:ea typeface="Arial"/>
+                <a:cs typeface="Arial"/>
+              </a:rPr>
+              <a:t>.</a:t>
+            </a:r>
+            <a:endParaRPr sz="1200" dirty="0">
               <a:latin typeface="Arial"/>
               <a:ea typeface="Arial"/>
               <a:cs typeface="Arial"/>
@@ -30053,15 +30613,527 @@
           </a:lstStyle>
           <a:p>
             <a:r>
-              <a:rPr sz="1000">
-                <a:latin typeface="Arial"/>
-                <a:ea typeface="Arial"/>
-                <a:cs typeface="Arial"/>
-              </a:rPr>
-              <a:t>US-007: Als Spieler möchte ich meinen Jeton-Kontostand nach jeder Änderung sofort angezeigt bekommen, damit ich jederzeit sehe, wie es um mich steht.
-Akzeptanz: Anzeige stimmt nach jedem Gewinn und Verlust; kein aktives Abfragen des Kontos; weitere Beobachter sind ohne Änderung am Konto anhängbar.</a:t>
-            </a:r>
-            <a:endParaRPr sz="1200">
+              <a:rPr sz="1000" dirty="0">
+                <a:latin typeface="Arial"/>
+                <a:ea typeface="Arial"/>
+                <a:cs typeface="Arial"/>
+              </a:rPr>
+              <a:t>US-00</a:t>
+            </a:r>
+            <a:r>
+              <a:rPr lang="de-CH" sz="1000" dirty="0">
+                <a:latin typeface="Arial"/>
+                <a:ea typeface="Arial"/>
+                <a:cs typeface="Arial"/>
+              </a:rPr>
+              <a:t>5</a:t>
+            </a:r>
+            <a:r>
+              <a:rPr sz="1000" dirty="0">
+                <a:latin typeface="Arial"/>
+                <a:ea typeface="Arial"/>
+                <a:cs typeface="Arial"/>
+              </a:rPr>
+              <a:t>: Als Spieler </a:t>
+            </a:r>
+            <a:r>
+              <a:rPr sz="1000" dirty="0" err="1">
+                <a:latin typeface="Arial"/>
+                <a:ea typeface="Arial"/>
+                <a:cs typeface="Arial"/>
+              </a:rPr>
+              <a:t>möchte</a:t>
+            </a:r>
+            <a:r>
+              <a:rPr sz="1000" dirty="0">
+                <a:latin typeface="Arial"/>
+                <a:ea typeface="Arial"/>
+                <a:cs typeface="Arial"/>
+              </a:rPr>
+              <a:t> ich </a:t>
+            </a:r>
+            <a:r>
+              <a:rPr sz="1000" dirty="0" err="1">
+                <a:latin typeface="Arial"/>
+                <a:ea typeface="Arial"/>
+                <a:cs typeface="Arial"/>
+              </a:rPr>
+              <a:t>meinen</a:t>
+            </a:r>
+            <a:r>
+              <a:rPr sz="1000" dirty="0">
+                <a:latin typeface="Arial"/>
+                <a:ea typeface="Arial"/>
+                <a:cs typeface="Arial"/>
+              </a:rPr>
+              <a:t> Jeton-</a:t>
+            </a:r>
+            <a:r>
+              <a:rPr sz="1000" dirty="0" err="1">
+                <a:latin typeface="Arial"/>
+                <a:ea typeface="Arial"/>
+                <a:cs typeface="Arial"/>
+              </a:rPr>
+              <a:t>Kontostand</a:t>
+            </a:r>
+            <a:r>
+              <a:rPr sz="1000" dirty="0">
+                <a:latin typeface="Arial"/>
+                <a:ea typeface="Arial"/>
+                <a:cs typeface="Arial"/>
+              </a:rPr>
+              <a:t> </a:t>
+            </a:r>
+            <a:r>
+              <a:rPr sz="1000" dirty="0" err="1">
+                <a:latin typeface="Arial"/>
+                <a:ea typeface="Arial"/>
+                <a:cs typeface="Arial"/>
+              </a:rPr>
+              <a:t>nach</a:t>
+            </a:r>
+            <a:r>
+              <a:rPr sz="1000" dirty="0">
+                <a:latin typeface="Arial"/>
+                <a:ea typeface="Arial"/>
+                <a:cs typeface="Arial"/>
+              </a:rPr>
+              <a:t> </a:t>
+            </a:r>
+            <a:r>
+              <a:rPr sz="1000" dirty="0" err="1">
+                <a:latin typeface="Arial"/>
+                <a:ea typeface="Arial"/>
+                <a:cs typeface="Arial"/>
+              </a:rPr>
+              <a:t>jeder</a:t>
+            </a:r>
+            <a:r>
+              <a:rPr sz="1000" dirty="0">
+                <a:latin typeface="Arial"/>
+                <a:ea typeface="Arial"/>
+                <a:cs typeface="Arial"/>
+              </a:rPr>
+              <a:t> </a:t>
+            </a:r>
+            <a:r>
+              <a:rPr sz="1000" dirty="0" err="1">
+                <a:latin typeface="Arial"/>
+                <a:ea typeface="Arial"/>
+                <a:cs typeface="Arial"/>
+              </a:rPr>
+              <a:t>Änderung</a:t>
+            </a:r>
+            <a:r>
+              <a:rPr sz="1000" dirty="0">
+                <a:latin typeface="Arial"/>
+                <a:ea typeface="Arial"/>
+                <a:cs typeface="Arial"/>
+              </a:rPr>
+              <a:t> </a:t>
+            </a:r>
+            <a:r>
+              <a:rPr sz="1000" dirty="0" err="1">
+                <a:latin typeface="Arial"/>
+                <a:ea typeface="Arial"/>
+                <a:cs typeface="Arial"/>
+              </a:rPr>
+              <a:t>sofort</a:t>
+            </a:r>
+            <a:r>
+              <a:rPr sz="1000" dirty="0">
+                <a:latin typeface="Arial"/>
+                <a:ea typeface="Arial"/>
+                <a:cs typeface="Arial"/>
+              </a:rPr>
+              <a:t> </a:t>
+            </a:r>
+            <a:r>
+              <a:rPr sz="1000" dirty="0" err="1">
+                <a:latin typeface="Arial"/>
+                <a:ea typeface="Arial"/>
+                <a:cs typeface="Arial"/>
+              </a:rPr>
+              <a:t>angezeigt</a:t>
+            </a:r>
+            <a:r>
+              <a:rPr sz="1000" dirty="0">
+                <a:latin typeface="Arial"/>
+                <a:ea typeface="Arial"/>
+                <a:cs typeface="Arial"/>
+              </a:rPr>
+              <a:t> </a:t>
+            </a:r>
+            <a:r>
+              <a:rPr sz="1000" dirty="0" err="1">
+                <a:latin typeface="Arial"/>
+                <a:ea typeface="Arial"/>
+                <a:cs typeface="Arial"/>
+              </a:rPr>
+              <a:t>bekommen</a:t>
+            </a:r>
+            <a:r>
+              <a:rPr sz="1000" dirty="0">
+                <a:latin typeface="Arial"/>
+                <a:ea typeface="Arial"/>
+                <a:cs typeface="Arial"/>
+              </a:rPr>
+              <a:t>, </a:t>
+            </a:r>
+            <a:r>
+              <a:rPr sz="1000" dirty="0" err="1">
+                <a:latin typeface="Arial"/>
+                <a:ea typeface="Arial"/>
+                <a:cs typeface="Arial"/>
+              </a:rPr>
+              <a:t>damit</a:t>
+            </a:r>
+            <a:r>
+              <a:rPr sz="1000" dirty="0">
+                <a:latin typeface="Arial"/>
+                <a:ea typeface="Arial"/>
+                <a:cs typeface="Arial"/>
+              </a:rPr>
+              <a:t> ich </a:t>
+            </a:r>
+            <a:r>
+              <a:rPr sz="1000" dirty="0" err="1">
+                <a:latin typeface="Arial"/>
+                <a:ea typeface="Arial"/>
+                <a:cs typeface="Arial"/>
+              </a:rPr>
+              <a:t>jederzeit</a:t>
+            </a:r>
+            <a:r>
+              <a:rPr sz="1000" dirty="0">
+                <a:latin typeface="Arial"/>
+                <a:ea typeface="Arial"/>
+                <a:cs typeface="Arial"/>
+              </a:rPr>
+              <a:t> </a:t>
+            </a:r>
+            <a:r>
+              <a:rPr sz="1000" dirty="0" err="1">
+                <a:latin typeface="Arial"/>
+                <a:ea typeface="Arial"/>
+                <a:cs typeface="Arial"/>
+              </a:rPr>
+              <a:t>sehe</a:t>
+            </a:r>
+            <a:r>
+              <a:rPr sz="1000" dirty="0">
+                <a:latin typeface="Arial"/>
+                <a:ea typeface="Arial"/>
+                <a:cs typeface="Arial"/>
+              </a:rPr>
+              <a:t>, </a:t>
+            </a:r>
+            <a:r>
+              <a:rPr sz="1000" dirty="0" err="1">
+                <a:latin typeface="Arial"/>
+                <a:ea typeface="Arial"/>
+                <a:cs typeface="Arial"/>
+              </a:rPr>
+              <a:t>wie</a:t>
+            </a:r>
+            <a:r>
+              <a:rPr sz="1000" dirty="0">
+                <a:latin typeface="Arial"/>
+                <a:ea typeface="Arial"/>
+                <a:cs typeface="Arial"/>
+              </a:rPr>
+              <a:t> es um </a:t>
+            </a:r>
+            <a:r>
+              <a:rPr sz="1000" dirty="0" err="1">
+                <a:latin typeface="Arial"/>
+                <a:ea typeface="Arial"/>
+                <a:cs typeface="Arial"/>
+              </a:rPr>
+              <a:t>mich</a:t>
+            </a:r>
+            <a:r>
+              <a:rPr sz="1000" dirty="0">
+                <a:latin typeface="Arial"/>
+                <a:ea typeface="Arial"/>
+                <a:cs typeface="Arial"/>
+              </a:rPr>
+              <a:t> </a:t>
+            </a:r>
+            <a:r>
+              <a:rPr sz="1000" dirty="0" err="1">
+                <a:latin typeface="Arial"/>
+                <a:ea typeface="Arial"/>
+                <a:cs typeface="Arial"/>
+              </a:rPr>
+              <a:t>steht</a:t>
+            </a:r>
+            <a:r>
+              <a:rPr sz="1000" dirty="0">
+                <a:latin typeface="Arial"/>
+                <a:ea typeface="Arial"/>
+                <a:cs typeface="Arial"/>
+              </a:rPr>
+              <a:t>.
+</a:t>
+            </a:r>
+            <a:r>
+              <a:rPr sz="1000" dirty="0" err="1">
+                <a:latin typeface="Arial"/>
+                <a:ea typeface="Arial"/>
+                <a:cs typeface="Arial"/>
+              </a:rPr>
+              <a:t>Akzeptanz</a:t>
+            </a:r>
+            <a:r>
+              <a:rPr sz="1000" dirty="0">
+                <a:latin typeface="Arial"/>
+                <a:ea typeface="Arial"/>
+                <a:cs typeface="Arial"/>
+              </a:rPr>
+              <a:t>: </a:t>
+            </a:r>
+            <a:r>
+              <a:rPr sz="1000" dirty="0" err="1">
+                <a:latin typeface="Arial"/>
+                <a:ea typeface="Arial"/>
+                <a:cs typeface="Arial"/>
+              </a:rPr>
+              <a:t>Anzeige</a:t>
+            </a:r>
+            <a:r>
+              <a:rPr sz="1000" dirty="0">
+                <a:latin typeface="Arial"/>
+                <a:ea typeface="Arial"/>
+                <a:cs typeface="Arial"/>
+              </a:rPr>
+              <a:t> </a:t>
+            </a:r>
+            <a:r>
+              <a:rPr sz="1000" dirty="0" err="1">
+                <a:latin typeface="Arial"/>
+                <a:ea typeface="Arial"/>
+                <a:cs typeface="Arial"/>
+              </a:rPr>
+              <a:t>stimmt</a:t>
+            </a:r>
+            <a:r>
+              <a:rPr sz="1000" dirty="0">
+                <a:latin typeface="Arial"/>
+                <a:ea typeface="Arial"/>
+                <a:cs typeface="Arial"/>
+              </a:rPr>
+              <a:t> </a:t>
+            </a:r>
+            <a:r>
+              <a:rPr sz="1000" dirty="0" err="1">
+                <a:latin typeface="Arial"/>
+                <a:ea typeface="Arial"/>
+                <a:cs typeface="Arial"/>
+              </a:rPr>
+              <a:t>nach</a:t>
+            </a:r>
+            <a:r>
+              <a:rPr sz="1000" dirty="0">
+                <a:latin typeface="Arial"/>
+                <a:ea typeface="Arial"/>
+                <a:cs typeface="Arial"/>
+              </a:rPr>
+              <a:t> </a:t>
+            </a:r>
+            <a:r>
+              <a:rPr sz="1000" dirty="0" err="1">
+                <a:latin typeface="Arial"/>
+                <a:ea typeface="Arial"/>
+                <a:cs typeface="Arial"/>
+              </a:rPr>
+              <a:t>jedem</a:t>
+            </a:r>
+            <a:r>
+              <a:rPr sz="1000" dirty="0">
+                <a:latin typeface="Arial"/>
+                <a:ea typeface="Arial"/>
+                <a:cs typeface="Arial"/>
+              </a:rPr>
+              <a:t> </a:t>
+            </a:r>
+            <a:r>
+              <a:rPr sz="1000" dirty="0" err="1">
+                <a:latin typeface="Arial"/>
+                <a:ea typeface="Arial"/>
+                <a:cs typeface="Arial"/>
+              </a:rPr>
+              <a:t>Gewinn</a:t>
+            </a:r>
+            <a:r>
+              <a:rPr sz="1000" dirty="0">
+                <a:latin typeface="Arial"/>
+                <a:ea typeface="Arial"/>
+                <a:cs typeface="Arial"/>
+              </a:rPr>
+              <a:t> und </a:t>
+            </a:r>
+            <a:r>
+              <a:rPr sz="1000" dirty="0" err="1">
+                <a:latin typeface="Arial"/>
+                <a:ea typeface="Arial"/>
+                <a:cs typeface="Arial"/>
+              </a:rPr>
+              <a:t>Verlust</a:t>
+            </a:r>
+            <a:r>
+              <a:rPr sz="1000" dirty="0">
+                <a:latin typeface="Arial"/>
+                <a:ea typeface="Arial"/>
+                <a:cs typeface="Arial"/>
+              </a:rPr>
+              <a:t>; </a:t>
+            </a:r>
+            <a:r>
+              <a:rPr sz="1000" dirty="0" err="1">
+                <a:latin typeface="Arial"/>
+                <a:ea typeface="Arial"/>
+                <a:cs typeface="Arial"/>
+              </a:rPr>
+              <a:t>kein</a:t>
+            </a:r>
+            <a:r>
+              <a:rPr sz="1000" dirty="0">
+                <a:latin typeface="Arial"/>
+                <a:ea typeface="Arial"/>
+                <a:cs typeface="Arial"/>
+              </a:rPr>
+              <a:t> </a:t>
+            </a:r>
+            <a:r>
+              <a:rPr sz="1000" dirty="0" err="1">
+                <a:latin typeface="Arial"/>
+                <a:ea typeface="Arial"/>
+                <a:cs typeface="Arial"/>
+              </a:rPr>
+              <a:t>aktives</a:t>
+            </a:r>
+            <a:r>
+              <a:rPr sz="1000" dirty="0">
+                <a:latin typeface="Arial"/>
+                <a:ea typeface="Arial"/>
+                <a:cs typeface="Arial"/>
+              </a:rPr>
+              <a:t> </a:t>
+            </a:r>
+            <a:r>
+              <a:rPr sz="1000" dirty="0" err="1">
+                <a:latin typeface="Arial"/>
+                <a:ea typeface="Arial"/>
+                <a:cs typeface="Arial"/>
+              </a:rPr>
+              <a:t>Abfragen</a:t>
+            </a:r>
+            <a:r>
+              <a:rPr sz="1000" dirty="0">
+                <a:latin typeface="Arial"/>
+                <a:ea typeface="Arial"/>
+                <a:cs typeface="Arial"/>
+              </a:rPr>
+              <a:t> des Kontos; </a:t>
+            </a:r>
+            <a:r>
+              <a:rPr sz="1000" dirty="0" err="1">
+                <a:latin typeface="Arial"/>
+                <a:ea typeface="Arial"/>
+                <a:cs typeface="Arial"/>
+              </a:rPr>
+              <a:t>weitere</a:t>
+            </a:r>
+            <a:r>
+              <a:rPr sz="1000" dirty="0">
+                <a:latin typeface="Arial"/>
+                <a:ea typeface="Arial"/>
+                <a:cs typeface="Arial"/>
+              </a:rPr>
+              <a:t> Beobachter </a:t>
+            </a:r>
+            <a:r>
+              <a:rPr sz="1000" dirty="0" err="1">
+                <a:latin typeface="Arial"/>
+                <a:ea typeface="Arial"/>
+                <a:cs typeface="Arial"/>
+              </a:rPr>
+              <a:t>sind</a:t>
+            </a:r>
+            <a:r>
+              <a:rPr sz="1000" dirty="0">
+                <a:latin typeface="Arial"/>
+                <a:ea typeface="Arial"/>
+                <a:cs typeface="Arial"/>
+              </a:rPr>
+              <a:t> </a:t>
+            </a:r>
+            <a:r>
+              <a:rPr sz="1000" dirty="0" err="1">
+                <a:latin typeface="Arial"/>
+                <a:ea typeface="Arial"/>
+                <a:cs typeface="Arial"/>
+              </a:rPr>
+              <a:t>ohne</a:t>
+            </a:r>
+            <a:r>
+              <a:rPr sz="1000" dirty="0">
+                <a:latin typeface="Arial"/>
+                <a:ea typeface="Arial"/>
+                <a:cs typeface="Arial"/>
+              </a:rPr>
+              <a:t> </a:t>
+            </a:r>
+            <a:r>
+              <a:rPr sz="1000" dirty="0" err="1">
+                <a:latin typeface="Arial"/>
+                <a:ea typeface="Arial"/>
+                <a:cs typeface="Arial"/>
+              </a:rPr>
+              <a:t>Änderung</a:t>
+            </a:r>
+            <a:r>
+              <a:rPr sz="1000" dirty="0">
+                <a:latin typeface="Arial"/>
+                <a:ea typeface="Arial"/>
+                <a:cs typeface="Arial"/>
+              </a:rPr>
+              <a:t> am </a:t>
+            </a:r>
+            <a:r>
+              <a:rPr sz="1000" dirty="0" err="1">
+                <a:latin typeface="Arial"/>
+                <a:ea typeface="Arial"/>
+                <a:cs typeface="Arial"/>
+              </a:rPr>
+              <a:t>Konto</a:t>
+            </a:r>
+            <a:r>
+              <a:rPr sz="1000" dirty="0">
+                <a:latin typeface="Arial"/>
+                <a:ea typeface="Arial"/>
+                <a:cs typeface="Arial"/>
+              </a:rPr>
+              <a:t> </a:t>
+            </a:r>
+            <a:r>
+              <a:rPr sz="1000" dirty="0" err="1">
+                <a:latin typeface="Arial"/>
+                <a:ea typeface="Arial"/>
+                <a:cs typeface="Arial"/>
+              </a:rPr>
+              <a:t>anhängbar</a:t>
+            </a:r>
+            <a:r>
+              <a:rPr sz="1000" dirty="0">
+                <a:latin typeface="Arial"/>
+                <a:ea typeface="Arial"/>
+                <a:cs typeface="Arial"/>
+              </a:rPr>
+              <a:t>.</a:t>
+            </a:r>
+            <a:endParaRPr sz="1200" dirty="0">
               <a:latin typeface="Arial"/>
               <a:ea typeface="Arial"/>
               <a:cs typeface="Arial"/>
@@ -35845,7 +36917,23 @@
                 <a:ea typeface="Arial"/>
                 <a:cs typeface="Arial"/>
               </a:rPr>
-              <a:t>US-008: Als Spieler </a:t>
+              <a:t>US-00</a:t>
+            </a:r>
+            <a:r>
+              <a:rPr lang="de-CH" sz="1000" dirty="0">
+                <a:latin typeface="Arial"/>
+                <a:ea typeface="Arial"/>
+                <a:cs typeface="Arial"/>
+              </a:rPr>
+              <a:t>6</a:t>
+            </a:r>
+            <a:r>
+              <a:rPr sz="1000" dirty="0">
+                <a:latin typeface="Arial"/>
+                <a:ea typeface="Arial"/>
+                <a:cs typeface="Arial"/>
+              </a:rPr>
+              <a:t>: Als Spieler </a:t>
             </a:r>
             <a:r>
               <a:rPr sz="1000" dirty="0" err="1">

</xml_diff>